<commit_message>
docs(deck): v2 deck: two wordings, the ruleset builder, six measures, new screenshots
</commit_message>
<xml_diff>
--- a/docs/deck/claim-sach-deck.pptx
+++ b/docs/deck/claim-sach-deck.pptx
@@ -114,7 +114,7 @@
   <p:extLst>
     <p:ext uri="{521415D9-36F7-43E2-AB2F-B90AF26B5E84}">
       <p14:sectionLst xmlns:p14="http://schemas.microsoft.com/office/powerpoint/2010/main">
-        <p14:section name="Pitch" id="{4276da25-b330-0f1e-4a42-fcb733c3e095}">
+        <p14:section name="Pitch" id="{7870e6d5-900d-607f-876a-610d5955bb41}">
           <p14:sldIdLst>
             <p14:sldId id="256"/>
             <p14:sldId id="257"/>
@@ -2041,7 +2041,7 @@
                   <a:schemeClr val="accent6"/>
                 </a:solidFill>
               </a:rPr>
-              <a:t>A working prototype: deterministic engine, 124 tests, runs offline. github.com/Pushkarmondal/paytm-hackathon</a:t>
+              <a:t>A working prototype: deterministic engine, 180 tests, a real IRDAI-hosted wording encoded and measured, runs offline. github.com/Pushkarmondal/paytm-hackathon</a:t>
             </a:r>
             <a:endParaRPr lang="en-US" sz="1400" dirty="0"/>
           </a:p>
@@ -3633,7 +3633,7 @@
       </p:sp>
       <p:sp>
         <p:nvSpPr>
-          <p:cNvPr id="8" name="card Data and ingestion"/>
+          <p:cNvPr id="8" name="card Two wordings"/>
           <p:cNvSpPr/>
           <p:nvPr/>
         </p:nvSpPr>
@@ -3660,7 +3660,7 @@
       </p:sp>
       <p:sp>
         <p:nvSpPr>
-          <p:cNvPr id="9" name="card text Data and ingestion"/>
+          <p:cNvPr id="9" name="card text Two wordings"/>
           <p:cNvSpPr txBox="1"/>
           <p:nvPr/>
         </p:nvSpPr>
@@ -3691,7 +3691,7 @@
                   <a:schemeClr val="accent5"/>
                 </a:solidFill>
               </a:rPr>
-              <a:t>Data and ingestion</a:t>
+              <a:t>Two wordings</a:t>
             </a:r>
             <a:endParaRPr lang="en-US" sz="1300" dirty="0"/>
           </a:p>
@@ -3708,7 +3708,7 @@
                   <a:schemeClr val="tx1"/>
                 </a:solidFill>
               </a:rPr>
-              <a:t>No database. Synthetic fixture in the box. JSON and CSV uploads validated with Zod, read in the browser only.</a:t>
+              <a:t>Synthetic demo policy, plus Arogya Sanjeevani (New India, irdai.gov.in): ten clauses verbatim, checksum shown.</a:t>
             </a:r>
             <a:endParaRPr lang="en-US" sz="1300" dirty="0"/>
           </a:p>
@@ -3725,7 +3725,7 @@
                   <a:schemeClr val="tx1"/>
                 </a:solidFill>
               </a:rPr>
-              <a:t>A rule that misquotes its clause is refused.</a:t>
+              <a:t>Partially encoded, labelled so.</a:t>
             </a:r>
             <a:endParaRPr lang="en-US" sz="1300" dirty="0"/>
           </a:p>
@@ -3808,7 +3808,7 @@
                   <a:schemeClr val="tx1"/>
                 </a:solidFill>
               </a:rPr>
-              <a:t>Deterministic retriever and extractor propose candidate clauses for a human to confirm.</a:t>
+              <a:t>Ruleset builder: a model proposes rules with quotes; the engine verifies each quote verbatim; a person confirms.</a:t>
             </a:r>
             <a:endParaRPr lang="en-US" sz="1300" dirty="0"/>
           </a:p>
@@ -3825,7 +3825,7 @@
                   <a:schemeClr val="tx1"/>
                 </a:solidFill>
               </a:rPr>
-              <a:t>An LLM adapter seam, off by default; never in the calculation path; the demo needs no key.</a:t>
+              <a:t>Cached in this build; adapter off.</a:t>
             </a:r>
             <a:endParaRPr lang="en-US" sz="1300" dirty="0"/>
           </a:p>
@@ -3908,7 +3908,7 @@
                   <a:schemeClr val="tx1"/>
                 </a:solidFill>
               </a:rPr>
-              <a:t>Vitest, 124 tests, test first. GitHub Actions on every PR.</a:t>
+              <a:t>Vitest, 180 tests, test first. GitHub Actions on every PR.</a:t>
             </a:r>
             <a:endParaRPr lang="en-US" sz="1300" dirty="0"/>
           </a:p>
@@ -3925,7 +3925,7 @@
                   <a:schemeClr val="tx1"/>
                 </a:solidFill>
               </a:rPr>
-              <a:t>Evaluation harness: four separate measures, results committed and checked for staleness.</a:t>
+              <a:t>Evaluation harness: six measures over two wordings, results committed and checked for staleness.</a:t>
             </a:r>
             <a:endParaRPr lang="en-US" sz="1300" dirty="0"/>
           </a:p>
@@ -4179,7 +4179,7 @@
       </p:sp>
       <p:pic>
         <p:nvPicPr>
-          <p:cNvPr id="4" name="trace screenshot" descr="Trace drawer: result as a range, plain-words explanation, the quoted clause, inputs with provenance">    </p:cNvPr>
+          <p:cNvPr id="4" name="builder screenshot" descr="Ruleset builder: proposals with verbatim-quote checks and agreement badges">    </p:cNvPr>
           <p:cNvPicPr>
             <a:picLocks noChangeAspect="1"/>
           </p:cNvPicPr>
@@ -4194,16 +4194,64 @@
         <p:spPr>
           <a:xfrm>
             <a:off x="457200" y="1371600"/>
-            <a:ext cx="2331720" cy="3200400"/>
+            <a:ext cx="2331720" cy="1632204"/>
           </a:xfrm>
           <a:prstGeom prst="rect">
             <a:avLst/>
           </a:prstGeom>
         </p:spPr>
       </p:pic>
-      <p:sp>
-        <p:nvSpPr>
-          <p:cNvPr id="5" name="pillar dot 1"/>
+      <p:pic>
+        <p:nvPicPr>
+          <p:cNvPr id="5" name="trace screenshot" descr="Trace drawer">    </p:cNvPr>
+          <p:cNvPicPr>
+            <a:picLocks noChangeAspect="1"/>
+          </p:cNvPicPr>
+          <p:nvPr/>
+        </p:nvPicPr>
+        <p:blipFill>
+          <a:blip r:embed="rId2"/>
+          <a:stretch>
+            <a:fillRect/>
+          </a:stretch>
+        </p:blipFill>
+        <p:spPr>
+          <a:xfrm>
+            <a:off x="457200" y="3108960"/>
+            <a:ext cx="1097280" cy="1508760"/>
+          </a:xfrm>
+          <a:prstGeom prst="rect">
+            <a:avLst/>
+          </a:prstGeom>
+        </p:spPr>
+      </p:pic>
+      <p:pic>
+        <p:nvPicPr>
+          <p:cNvPr id="6" name="real wording screenshot" descr="The real wording in the overview">    </p:cNvPr>
+          <p:cNvPicPr>
+            <a:picLocks noChangeAspect="1"/>
+          </p:cNvPicPr>
+          <p:nvPr/>
+        </p:nvPicPr>
+        <p:blipFill>
+          <a:blip r:embed="rId3"/>
+          <a:stretch>
+            <a:fillRect/>
+          </a:stretch>
+        </p:blipFill>
+        <p:spPr>
+          <a:xfrm>
+            <a:off x="1645920" y="3108960"/>
+            <a:ext cx="1143000" cy="859536"/>
+          </a:xfrm>
+          <a:prstGeom prst="rect">
+            <a:avLst/>
+          </a:prstGeom>
+        </p:spPr>
+      </p:pic>
+      <p:sp>
+        <p:nvSpPr>
+          <p:cNvPr id="7" name="pillar dot 1"/>
           <p:cNvSpPr/>
           <p:nvPr/>
         </p:nvSpPr>
@@ -4228,7 +4276,7 @@
       </p:sp>
       <p:sp>
         <p:nvSpPr>
-          <p:cNvPr id="6" name="pillar number 1"/>
+          <p:cNvPr id="8" name="pillar number 1"/>
           <p:cNvSpPr txBox="1"/>
           <p:nvPr/>
         </p:nvSpPr>
@@ -4264,7 +4312,7 @@
       </p:sp>
       <p:sp>
         <p:nvSpPr>
-          <p:cNvPr id="7" name="pillar text 1"/>
+          <p:cNvPr id="9" name="pillar text 1"/>
           <p:cNvSpPr txBox="1"/>
           <p:nvPr/>
         </p:nvSpPr>
@@ -4317,7 +4365,7 @@
       </p:sp>
       <p:sp>
         <p:nvSpPr>
-          <p:cNvPr id="8" name="pillar dot 2"/>
+          <p:cNvPr id="10" name="pillar dot 2"/>
           <p:cNvSpPr/>
           <p:nvPr/>
         </p:nvSpPr>
@@ -4342,7 +4390,7 @@
       </p:sp>
       <p:sp>
         <p:nvSpPr>
-          <p:cNvPr id="9" name="pillar number 2"/>
+          <p:cNvPr id="11" name="pillar number 2"/>
           <p:cNvSpPr txBox="1"/>
           <p:nvPr/>
         </p:nvSpPr>
@@ -4378,7 +4426,7 @@
       </p:sp>
       <p:sp>
         <p:nvSpPr>
-          <p:cNvPr id="10" name="pillar text 2"/>
+          <p:cNvPr id="12" name="pillar text 2"/>
           <p:cNvSpPr txBox="1"/>
           <p:nvPr/>
         </p:nvSpPr>
@@ -4431,7 +4479,7 @@
       </p:sp>
       <p:sp>
         <p:nvSpPr>
-          <p:cNvPr id="11" name="pillar dot 3"/>
+          <p:cNvPr id="13" name="pillar dot 3"/>
           <p:cNvSpPr/>
           <p:nvPr/>
         </p:nvSpPr>
@@ -4456,7 +4504,7 @@
       </p:sp>
       <p:sp>
         <p:nvSpPr>
-          <p:cNvPr id="12" name="pillar number 3"/>
+          <p:cNvPr id="14" name="pillar number 3"/>
           <p:cNvSpPr txBox="1"/>
           <p:nvPr/>
         </p:nvSpPr>
@@ -4492,7 +4540,7 @@
       </p:sp>
       <p:sp>
         <p:nvSpPr>
-          <p:cNvPr id="13" name="pillar text 3"/>
+          <p:cNvPr id="15" name="pillar text 3"/>
           <p:cNvSpPr txBox="1"/>
           <p:nvPr/>
         </p:nvSpPr>
@@ -4537,7 +4585,7 @@
                   <a:schemeClr val="tx2"/>
                 </a:solidFill>
               </a:rPr>
-              <a:t>Two rooms side by side on one policy and one estimate, with the rule behind every changed row.</a:t>
+              <a:t>Two rooms side by side, the rule behind every changed row; the room ladder and the question sheet turn it into a decision and a call script.</a:t>
             </a:r>
             <a:endParaRPr lang="en-US" sz="1400" dirty="0"/>
           </a:p>
@@ -4545,7 +4593,7 @@
       </p:sp>
       <p:sp>
         <p:nvSpPr>
-          <p:cNvPr id="14" name="pillar dot 4"/>
+          <p:cNvPr id="16" name="pillar dot 4"/>
           <p:cNvSpPr/>
           <p:nvPr/>
         </p:nvSpPr>
@@ -4570,7 +4618,7 @@
       </p:sp>
       <p:sp>
         <p:nvSpPr>
-          <p:cNvPr id="15" name="pillar number 4"/>
+          <p:cNvPr id="17" name="pillar number 4"/>
           <p:cNvSpPr txBox="1"/>
           <p:nvPr/>
         </p:nvSpPr>
@@ -4606,7 +4654,7 @@
       </p:sp>
       <p:sp>
         <p:nvSpPr>
-          <p:cNvPr id="16" name="pillar text 4"/>
+          <p:cNvPr id="18" name="pillar text 4"/>
           <p:cNvSpPr txBox="1"/>
           <p:nvPr/>
         </p:nvSpPr>
@@ -4637,7 +4685,7 @@
                   <a:schemeClr val="tx1"/>
                 </a:solidFill>
               </a:rPr>
-              <a:t>Honest scope</a:t>
+              <a:t>Proven on a real wording, honestly</a:t>
             </a:r>
             <a:endParaRPr lang="en-US" sz="1400" dirty="0"/>
           </a:p>
@@ -4651,7 +4699,7 @@
                   <a:schemeClr val="tx2"/>
                 </a:solidFill>
               </a:rPr>
-              <a:t>The figure is the potential deductions covered by the simulation, never a total. Terms not modelled are listed on screen.</a:t>
+              <a:t>Arogya Sanjeevani, ten clauses verbatim with a checksum; where the 2019-20 text conflicts with IRDAI's 2020 norms, the engine says so.</a:t>
             </a:r>
             <a:endParaRPr lang="en-US" sz="1400" dirty="0"/>
           </a:p>
@@ -4659,7 +4707,7 @@
       </p:sp>
       <p:sp>
         <p:nvSpPr>
-          <p:cNvPr id="17" name="usp caption"/>
+          <p:cNvPr id="19" name="usp caption"/>
           <p:cNvSpPr txBox="1"/>
           <p:nvPr/>
         </p:nvSpPr>
@@ -5125,11 +5173,11 @@
             <a:tbl>
               <a:tblPr/>
               <a:tblGrid>
-                <a:gridCol w="1920240"/>
-                <a:gridCol w="731520"/>
-                <a:gridCol w="1463040"/>
+                <a:gridCol w="2194560"/>
+                <a:gridCol w="960120"/>
+                <a:gridCol w="960120"/>
               </a:tblGrid>
-              <a:tr h="310896">
+              <a:tr h="274320">
                 <a:tc>
                   <a:txBody>
                     <a:bodyPr/>
@@ -5139,7 +5187,7 @@
                         <a:buNone/>
                       </a:pPr>
                       <a:r>
-                        <a:rPr lang="en-US" sz="1050" b="1" dirty="0">
+                        <a:rPr lang="en-US" sz="950" b="1" dirty="0">
                           <a:solidFill>
                             <a:srgbClr val="1C1917"/>
                           </a:solidFill>
@@ -5149,14 +5197,14 @@
                         </a:rPr>
                         <a:t>Measure</a:t>
                       </a:r>
-                      <a:endParaRPr lang="en-US" sz="1050" dirty="0">
+                      <a:endParaRPr lang="en-US" sz="950" dirty="0">
                         <a:latin typeface="Calibri" charset="0"/>
                         <a:ea typeface="Calibri" charset="0"/>
                         <a:cs typeface="Calibri" charset="0"/>
                       </a:endParaRPr>
                     </a:p>
                   </a:txBody>
-                  <a:tcPr marL="45720" marR="45720" marT="45720" marB="45720" anchor="ctr">
+                  <a:tcPr marL="36576" marR="36576" marT="36576" marB="36576" anchor="ctr">
                     <a:lnL w="6350" cap="flat" cmpd="sng" algn="ctr">
                       <a:solidFill>
                         <a:srgbClr val="D6D3D1"/>
@@ -5207,7 +5255,7 @@
                         <a:buNone/>
                       </a:pPr>
                       <a:r>
-                        <a:rPr lang="en-US" sz="1050" b="1" dirty="0">
+                        <a:rPr lang="en-US" sz="950" b="1" dirty="0">
                           <a:solidFill>
                             <a:srgbClr val="1C1917"/>
                           </a:solidFill>
@@ -5215,16 +5263,16 @@
                           <a:ea typeface="Calibri" pitchFamily="34" charset="-122"/>
                           <a:cs typeface="Calibri" pitchFamily="34" charset="-120"/>
                         </a:rPr>
-                        <a:t>Result</a:t>
+                        <a:t>Synthetic</a:t>
                       </a:r>
-                      <a:endParaRPr lang="en-US" sz="1050" dirty="0">
+                      <a:endParaRPr lang="en-US" sz="950" dirty="0">
                         <a:latin typeface="Calibri" charset="0"/>
                         <a:ea typeface="Calibri" charset="0"/>
                         <a:cs typeface="Calibri" charset="0"/>
                       </a:endParaRPr>
                     </a:p>
                   </a:txBody>
-                  <a:tcPr marL="45720" marR="45720" marT="45720" marB="45720" anchor="ctr">
+                  <a:tcPr marL="36576" marR="36576" marT="36576" marB="36576" anchor="ctr">
                     <a:lnL w="6350" cap="flat" cmpd="sng" algn="ctr">
                       <a:solidFill>
                         <a:srgbClr val="D6D3D1"/>
@@ -5275,7 +5323,7 @@
                         <a:buNone/>
                       </a:pPr>
                       <a:r>
-                        <a:rPr lang="en-US" sz="1050" b="1" dirty="0">
+                        <a:rPr lang="en-US" sz="950" b="1" dirty="0">
                           <a:solidFill>
                             <a:srgbClr val="1C1917"/>
                           </a:solidFill>
@@ -5283,16 +5331,16 @@
                           <a:ea typeface="Calibri" pitchFamily="34" charset="-122"/>
                           <a:cs typeface="Calibri" pitchFamily="34" charset="-120"/>
                         </a:rPr>
-                        <a:t>Dataset</a:t>
+                        <a:t>Real wording</a:t>
                       </a:r>
-                      <a:endParaRPr lang="en-US" sz="1050" dirty="0">
+                      <a:endParaRPr lang="en-US" sz="950" dirty="0">
                         <a:latin typeface="Calibri" charset="0"/>
                         <a:ea typeface="Calibri" charset="0"/>
                         <a:cs typeface="Calibri" charset="0"/>
                       </a:endParaRPr>
                     </a:p>
                   </a:txBody>
-                  <a:tcPr marL="45720" marR="45720" marT="45720" marB="45720" anchor="ctr">
+                  <a:tcPr marL="36576" marR="36576" marT="36576" marB="36576" anchor="ctr">
                     <a:lnL w="6350" cap="flat" cmpd="sng" algn="ctr">
                       <a:solidFill>
                         <a:srgbClr val="D6D3D1"/>
@@ -5335,7 +5383,7 @@
                   </a:tcPr>
                 </a:tc>
               </a:tr>
-              <a:tr h="310896">
+              <a:tr h="274320">
                 <a:tc>
                   <a:txBody>
                     <a:bodyPr/>
@@ -5345,7 +5393,7 @@
                         <a:buNone/>
                       </a:pPr>
                       <a:r>
-                        <a:rPr lang="en-US" sz="1050" dirty="0">
+                        <a:rPr lang="en-US" sz="950" dirty="0">
                           <a:solidFill>
                             <a:srgbClr val="1C1917"/>
                           </a:solidFill>
@@ -5355,14 +5403,14 @@
                         </a:rPr>
                         <a:t>Clause retrieval, top-1</a:t>
                       </a:r>
-                      <a:endParaRPr lang="en-US" sz="1050" dirty="0">
+                      <a:endParaRPr lang="en-US" sz="950" dirty="0">
                         <a:latin typeface="Calibri" charset="0"/>
                         <a:ea typeface="Calibri" charset="0"/>
                         <a:cs typeface="Calibri" charset="0"/>
                       </a:endParaRPr>
                     </a:p>
                   </a:txBody>
-                  <a:tcPr marL="45720" marR="45720" marT="45720" marB="45720" anchor="ctr">
+                  <a:tcPr marL="36576" marR="36576" marT="36576" marB="36576" anchor="ctr">
                     <a:lnL w="6350" cap="flat" cmpd="sng" algn="ctr">
                       <a:solidFill>
                         <a:srgbClr val="D6D3D1"/>
@@ -5413,7 +5461,7 @@
                         <a:buNone/>
                       </a:pPr>
                       <a:r>
-                        <a:rPr lang="en-US" sz="1050" dirty="0">
+                        <a:rPr lang="en-US" sz="950" dirty="0">
                           <a:solidFill>
                             <a:srgbClr val="1C1917"/>
                           </a:solidFill>
@@ -5423,14 +5471,14 @@
                         </a:rPr>
                         <a:t>11 of 12</a:t>
                       </a:r>
-                      <a:endParaRPr lang="en-US" sz="1050" dirty="0">
+                      <a:endParaRPr lang="en-US" sz="950" dirty="0">
                         <a:latin typeface="Calibri" charset="0"/>
                         <a:ea typeface="Calibri" charset="0"/>
                         <a:cs typeface="Calibri" charset="0"/>
                       </a:endParaRPr>
                     </a:p>
                   </a:txBody>
-                  <a:tcPr marL="45720" marR="45720" marT="45720" marB="45720" anchor="ctr">
+                  <a:tcPr marL="36576" marR="36576" marT="36576" marB="36576" anchor="ctr">
                     <a:lnL w="6350" cap="flat" cmpd="sng" algn="ctr">
                       <a:solidFill>
                         <a:srgbClr val="D6D3D1"/>
@@ -5481,7 +5529,7 @@
                         <a:buNone/>
                       </a:pPr>
                       <a:r>
-                        <a:rPr lang="en-US" sz="1050" dirty="0">
+                        <a:rPr lang="en-US" sz="950" dirty="0">
                           <a:solidFill>
                             <a:srgbClr val="1C1917"/>
                           </a:solidFill>
@@ -5489,16 +5537,16 @@
                           <a:ea typeface="Calibri" pitchFamily="34" charset="-122"/>
                           <a:cs typeface="Calibri" pitchFamily="34" charset="-120"/>
                         </a:rPr>
-                        <a:t>12 questions, synthetic wording</a:t>
+                        <a:t>10 of 12</a:t>
                       </a:r>
-                      <a:endParaRPr lang="en-US" sz="1050" dirty="0">
+                      <a:endParaRPr lang="en-US" sz="950" dirty="0">
                         <a:latin typeface="Calibri" charset="0"/>
                         <a:ea typeface="Calibri" charset="0"/>
                         <a:cs typeface="Calibri" charset="0"/>
                       </a:endParaRPr>
                     </a:p>
                   </a:txBody>
-                  <a:tcPr marL="45720" marR="45720" marT="45720" marB="45720" anchor="ctr">
+                  <a:tcPr marL="36576" marR="36576" marT="36576" marB="36576" anchor="ctr">
                     <a:lnL w="6350" cap="flat" cmpd="sng" algn="ctr">
                       <a:solidFill>
                         <a:srgbClr val="D6D3D1"/>
@@ -5541,7 +5589,7 @@
                   </a:tcPr>
                 </a:tc>
               </a:tr>
-              <a:tr h="310896">
+              <a:tr h="274320">
                 <a:tc>
                   <a:txBody>
                     <a:bodyPr/>
@@ -5551,7 +5599,7 @@
                         <a:buNone/>
                       </a:pPr>
                       <a:r>
-                        <a:rPr lang="en-US" sz="1050" dirty="0">
+                        <a:rPr lang="en-US" sz="950" dirty="0">
                           <a:solidFill>
                             <a:srgbClr val="1C1917"/>
                           </a:solidFill>
@@ -5561,14 +5609,14 @@
                         </a:rPr>
                         <a:t>Rule extraction, field-level</a:t>
                       </a:r>
-                      <a:endParaRPr lang="en-US" sz="1050" dirty="0">
+                      <a:endParaRPr lang="en-US" sz="950" dirty="0">
                         <a:latin typeface="Calibri" charset="0"/>
                         <a:ea typeface="Calibri" charset="0"/>
                         <a:cs typeface="Calibri" charset="0"/>
                       </a:endParaRPr>
                     </a:p>
                   </a:txBody>
-                  <a:tcPr marL="45720" marR="45720" marT="45720" marB="45720" anchor="ctr">
+                  <a:tcPr marL="36576" marR="36576" marT="36576" marB="36576" anchor="ctr">
                     <a:lnL w="6350" cap="flat" cmpd="sng" algn="ctr">
                       <a:solidFill>
                         <a:srgbClr val="D6D3D1"/>
@@ -5619,7 +5667,7 @@
                         <a:buNone/>
                       </a:pPr>
                       <a:r>
-                        <a:rPr lang="en-US" sz="1050" dirty="0">
+                        <a:rPr lang="en-US" sz="950" dirty="0">
                           <a:solidFill>
                             <a:srgbClr val="1C1917"/>
                           </a:solidFill>
@@ -5629,14 +5677,14 @@
                         </a:rPr>
                         <a:t>10 of 10</a:t>
                       </a:r>
-                      <a:endParaRPr lang="en-US" sz="1050" dirty="0">
+                      <a:endParaRPr lang="en-US" sz="950" dirty="0">
                         <a:latin typeface="Calibri" charset="0"/>
                         <a:ea typeface="Calibri" charset="0"/>
                         <a:cs typeface="Calibri" charset="0"/>
                       </a:endParaRPr>
                     </a:p>
                   </a:txBody>
-                  <a:tcPr marL="45720" marR="45720" marT="45720" marB="45720" anchor="ctr">
+                  <a:tcPr marL="36576" marR="36576" marT="36576" marB="36576" anchor="ctr">
                     <a:lnL w="6350" cap="flat" cmpd="sng" algn="ctr">
                       <a:solidFill>
                         <a:srgbClr val="D6D3D1"/>
@@ -5687,7 +5735,7 @@
                         <a:buNone/>
                       </a:pPr>
                       <a:r>
-                        <a:rPr lang="en-US" sz="1050" dirty="0">
+                        <a:rPr lang="en-US" sz="950" dirty="0">
                           <a:solidFill>
                             <a:srgbClr val="1C1917"/>
                           </a:solidFill>
@@ -5695,16 +5743,16 @@
                           <a:ea typeface="Calibri" pitchFamily="34" charset="-122"/>
                           <a:cs typeface="Calibri" pitchFamily="34" charset="-120"/>
                         </a:rPr>
-                        <a:t>10 rule fields</a:t>
+                        <a:t>10 of 12</a:t>
                       </a:r>
-                      <a:endParaRPr lang="en-US" sz="1050" dirty="0">
+                      <a:endParaRPr lang="en-US" sz="950" dirty="0">
                         <a:latin typeface="Calibri" charset="0"/>
                         <a:ea typeface="Calibri" charset="0"/>
                         <a:cs typeface="Calibri" charset="0"/>
                       </a:endParaRPr>
                     </a:p>
                   </a:txBody>
-                  <a:tcPr marL="45720" marR="45720" marT="45720" marB="45720" anchor="ctr">
+                  <a:tcPr marL="36576" marR="36576" marT="36576" marB="36576" anchor="ctr">
                     <a:lnL w="6350" cap="flat" cmpd="sng" algn="ctr">
                       <a:solidFill>
                         <a:srgbClr val="D6D3D1"/>
@@ -5747,7 +5795,7 @@
                   </a:tcPr>
                 </a:tc>
               </a:tr>
-              <a:tr h="310896">
+              <a:tr h="274320">
                 <a:tc>
                   <a:txBody>
                     <a:bodyPr/>
@@ -5757,7 +5805,7 @@
                         <a:buNone/>
                       </a:pPr>
                       <a:r>
-                        <a:rPr lang="en-US" sz="1050" dirty="0">
+                        <a:rPr lang="en-US" sz="950" dirty="0">
                           <a:solidFill>
                             <a:srgbClr val="1C1917"/>
                           </a:solidFill>
@@ -5765,16 +5813,16 @@
                           <a:ea typeface="Calibri" pitchFamily="34" charset="-122"/>
                           <a:cs typeface="Calibri" pitchFamily="34" charset="-120"/>
                         </a:rPr>
-                        <a:t>Calculation correctness, exact paise</a:t>
+                        <a:t>Calculations, exact paise</a:t>
                       </a:r>
-                      <a:endParaRPr lang="en-US" sz="1050" dirty="0">
+                      <a:endParaRPr lang="en-US" sz="950" dirty="0">
                         <a:latin typeface="Calibri" charset="0"/>
                         <a:ea typeface="Calibri" charset="0"/>
                         <a:cs typeface="Calibri" charset="0"/>
                       </a:endParaRPr>
                     </a:p>
                   </a:txBody>
-                  <a:tcPr marL="45720" marR="45720" marT="45720" marB="45720" anchor="ctr">
+                  <a:tcPr marL="36576" marR="36576" marT="36576" marB="36576" anchor="ctr">
                     <a:lnL w="6350" cap="flat" cmpd="sng" algn="ctr">
                       <a:solidFill>
                         <a:srgbClr val="D6D3D1"/>
@@ -5825,7 +5873,7 @@
                         <a:buNone/>
                       </a:pPr>
                       <a:r>
-                        <a:rPr lang="en-US" sz="1050" dirty="0">
+                        <a:rPr lang="en-US" sz="950" dirty="0">
                           <a:solidFill>
                             <a:srgbClr val="1C1917"/>
                           </a:solidFill>
@@ -5833,16 +5881,16 @@
                           <a:ea typeface="Calibri" pitchFamily="34" charset="-122"/>
                           <a:cs typeface="Calibri" pitchFamily="34" charset="-120"/>
                         </a:rPr>
-                        <a:t>9 of 9</a:t>
+                        <a:t>9 of 9 (46 amounts)</a:t>
                       </a:r>
-                      <a:endParaRPr lang="en-US" sz="1050" dirty="0">
+                      <a:endParaRPr lang="en-US" sz="950" dirty="0">
                         <a:latin typeface="Calibri" charset="0"/>
                         <a:ea typeface="Calibri" charset="0"/>
                         <a:cs typeface="Calibri" charset="0"/>
                       </a:endParaRPr>
                     </a:p>
                   </a:txBody>
-                  <a:tcPr marL="45720" marR="45720" marT="45720" marB="45720" anchor="ctr">
+                  <a:tcPr marL="36576" marR="36576" marT="36576" marB="36576" anchor="ctr">
                     <a:lnL w="6350" cap="flat" cmpd="sng" algn="ctr">
                       <a:solidFill>
                         <a:srgbClr val="D6D3D1"/>
@@ -5893,7 +5941,7 @@
                         <a:buNone/>
                       </a:pPr>
                       <a:r>
-                        <a:rPr lang="en-US" sz="1050" dirty="0">
+                        <a:rPr lang="en-US" sz="950" dirty="0">
                           <a:solidFill>
                             <a:srgbClr val="1C1917"/>
                           </a:solidFill>
@@ -5901,16 +5949,16 @@
                           <a:ea typeface="Calibri" pitchFamily="34" charset="-122"/>
                           <a:cs typeface="Calibri" pitchFamily="34" charset="-120"/>
                         </a:rPr>
-                        <a:t>9 scenarios, 46 amounts</a:t>
+                        <a:t>3 of 3 (21 amounts)</a:t>
                       </a:r>
-                      <a:endParaRPr lang="en-US" sz="1050" dirty="0">
+                      <a:endParaRPr lang="en-US" sz="950" dirty="0">
                         <a:latin typeface="Calibri" charset="0"/>
                         <a:ea typeface="Calibri" charset="0"/>
                         <a:cs typeface="Calibri" charset="0"/>
                       </a:endParaRPr>
                     </a:p>
                   </a:txBody>
-                  <a:tcPr marL="45720" marR="45720" marT="45720" marB="45720" anchor="ctr">
+                  <a:tcPr marL="36576" marR="36576" marT="36576" marB="36576" anchor="ctr">
                     <a:lnL w="6350" cap="flat" cmpd="sng" algn="ctr">
                       <a:solidFill>
                         <a:srgbClr val="D6D3D1"/>
@@ -5953,7 +6001,7 @@
                   </a:tcPr>
                 </a:tc>
               </a:tr>
-              <a:tr h="310896">
+              <a:tr h="274320">
                 <a:tc>
                   <a:txBody>
                     <a:bodyPr/>
@@ -5963,7 +6011,7 @@
                         <a:buNone/>
                       </a:pPr>
                       <a:r>
-                        <a:rPr lang="en-US" sz="1050" dirty="0">
+                        <a:rPr lang="en-US" sz="950" dirty="0">
                           <a:solidFill>
                             <a:srgbClr val="1C1917"/>
                           </a:solidFill>
@@ -5971,16 +6019,16 @@
                           <a:ea typeface="Calibri" pitchFamily="34" charset="-122"/>
                           <a:cs typeface="Calibri" pitchFamily="34" charset="-120"/>
                         </a:rPr>
-                        <a:t>Uncertainty and refusal quality</a:t>
+                        <a:t>Uncertainty and refusal</a:t>
                       </a:r>
-                      <a:endParaRPr lang="en-US" sz="1050" dirty="0">
+                      <a:endParaRPr lang="en-US" sz="950" dirty="0">
                         <a:latin typeface="Calibri" charset="0"/>
                         <a:ea typeface="Calibri" charset="0"/>
                         <a:cs typeface="Calibri" charset="0"/>
                       </a:endParaRPr>
                     </a:p>
                   </a:txBody>
-                  <a:tcPr marL="45720" marR="45720" marT="45720" marB="45720" anchor="ctr">
+                  <a:tcPr marL="36576" marR="36576" marT="36576" marB="36576" anchor="ctr">
                     <a:lnL w="6350" cap="flat" cmpd="sng" algn="ctr">
                       <a:solidFill>
                         <a:srgbClr val="D6D3D1"/>
@@ -6031,7 +6079,7 @@
                         <a:buNone/>
                       </a:pPr>
                       <a:r>
-                        <a:rPr lang="en-US" sz="1050" dirty="0">
+                        <a:rPr lang="en-US" sz="950" dirty="0">
                           <a:solidFill>
                             <a:srgbClr val="1C1917"/>
                           </a:solidFill>
@@ -6041,14 +6089,14 @@
                         </a:rPr>
                         <a:t>6 of 6</a:t>
                       </a:r>
-                      <a:endParaRPr lang="en-US" sz="1050" dirty="0">
+                      <a:endParaRPr lang="en-US" sz="950" dirty="0">
                         <a:latin typeface="Calibri" charset="0"/>
                         <a:ea typeface="Calibri" charset="0"/>
                         <a:cs typeface="Calibri" charset="0"/>
                       </a:endParaRPr>
                     </a:p>
                   </a:txBody>
-                  <a:tcPr marL="45720" marR="45720" marT="45720" marB="45720" anchor="ctr">
+                  <a:tcPr marL="36576" marR="36576" marT="36576" marB="36576" anchor="ctr">
                     <a:lnL w="6350" cap="flat" cmpd="sng" algn="ctr">
                       <a:solidFill>
                         <a:srgbClr val="D6D3D1"/>
@@ -6099,7 +6147,7 @@
                         <a:buNone/>
                       </a:pPr>
                       <a:r>
-                        <a:rPr lang="en-US" sz="1050" dirty="0">
+                        <a:rPr lang="en-US" sz="950" dirty="0">
                           <a:solidFill>
                             <a:srgbClr val="1C1917"/>
                           </a:solidFill>
@@ -6107,16 +6155,428 @@
                           <a:ea typeface="Calibri" pitchFamily="34" charset="-122"/>
                           <a:cs typeface="Calibri" pitchFamily="34" charset="-120"/>
                         </a:rPr>
-                        <a:t>6 cases</a:t>
+                        <a:t>3 of 3</a:t>
                       </a:r>
-                      <a:endParaRPr lang="en-US" sz="1050" dirty="0">
+                      <a:endParaRPr lang="en-US" sz="950" dirty="0">
                         <a:latin typeface="Calibri" charset="0"/>
                         <a:ea typeface="Calibri" charset="0"/>
                         <a:cs typeface="Calibri" charset="0"/>
                       </a:endParaRPr>
                     </a:p>
                   </a:txBody>
-                  <a:tcPr marL="45720" marR="45720" marT="45720" marB="45720" anchor="ctr">
+                  <a:tcPr marL="36576" marR="36576" marT="36576" marB="36576" anchor="ctr">
+                    <a:lnL w="6350" cap="flat" cmpd="sng" algn="ctr">
+                      <a:solidFill>
+                        <a:srgbClr val="D6D3D1"/>
+                      </a:solidFill>
+                      <a:prstDash val="solid"/>
+                      <a:round/>
+                      <a:headEnd type="none" w="med" len="med"/>
+                      <a:tailEnd type="none" w="med" len="med"/>
+                    </a:lnL>
+                    <a:lnR w="6350" cap="flat" cmpd="sng" algn="ctr">
+                      <a:solidFill>
+                        <a:srgbClr val="D6D3D1"/>
+                      </a:solidFill>
+                      <a:prstDash val="solid"/>
+                      <a:round/>
+                      <a:headEnd type="none" w="med" len="med"/>
+                      <a:tailEnd type="none" w="med" len="med"/>
+                    </a:lnR>
+                    <a:lnT w="6350" cap="flat" cmpd="sng" algn="ctr">
+                      <a:solidFill>
+                        <a:srgbClr val="D6D3D1"/>
+                      </a:solidFill>
+                      <a:prstDash val="solid"/>
+                      <a:round/>
+                      <a:headEnd type="none" w="med" len="med"/>
+                      <a:tailEnd type="none" w="med" len="med"/>
+                    </a:lnT>
+                    <a:lnB w="6350" cap="flat" cmpd="sng" algn="ctr">
+                      <a:solidFill>
+                        <a:srgbClr val="D6D3D1"/>
+                      </a:solidFill>
+                      <a:prstDash val="solid"/>
+                      <a:round/>
+                      <a:headEnd type="none" w="med" len="med"/>
+                      <a:tailEnd type="none" w="med" len="med"/>
+                    </a:lnB>
+                    <a:solidFill>
+                      <a:srgbClr val="FFFFFF"/>
+                    </a:solidFill>
+                  </a:tcPr>
+                </a:tc>
+              </a:tr>
+              <a:tr h="274320">
+                <a:tc>
+                  <a:txBody>
+                    <a:bodyPr/>
+                    <a:lstStyle/>
+                    <a:p>
+                      <a:pPr indent="0" marL="0">
+                        <a:buNone/>
+                      </a:pPr>
+                      <a:r>
+                        <a:rPr lang="en-US" sz="950" dirty="0">
+                          <a:solidFill>
+                            <a:srgbClr val="1C1917"/>
+                          </a:solidFill>
+                          <a:latin typeface="Calibri" pitchFamily="34" charset="0"/>
+                          <a:ea typeface="Calibri" pitchFamily="34" charset="-122"/>
+                          <a:cs typeface="Calibri" pitchFamily="34" charset="-120"/>
+                        </a:rPr>
+                        <a:t>Model proposals: quotes verbatim (cached)</a:t>
+                      </a:r>
+                      <a:endParaRPr lang="en-US" sz="950" dirty="0">
+                        <a:latin typeface="Calibri" charset="0"/>
+                        <a:ea typeface="Calibri" charset="0"/>
+                        <a:cs typeface="Calibri" charset="0"/>
+                      </a:endParaRPr>
+                    </a:p>
+                  </a:txBody>
+                  <a:tcPr marL="36576" marR="36576" marT="36576" marB="36576" anchor="ctr">
+                    <a:lnL w="6350" cap="flat" cmpd="sng" algn="ctr">
+                      <a:solidFill>
+                        <a:srgbClr val="D6D3D1"/>
+                      </a:solidFill>
+                      <a:prstDash val="solid"/>
+                      <a:round/>
+                      <a:headEnd type="none" w="med" len="med"/>
+                      <a:tailEnd type="none" w="med" len="med"/>
+                    </a:lnL>
+                    <a:lnR w="6350" cap="flat" cmpd="sng" algn="ctr">
+                      <a:solidFill>
+                        <a:srgbClr val="D6D3D1"/>
+                      </a:solidFill>
+                      <a:prstDash val="solid"/>
+                      <a:round/>
+                      <a:headEnd type="none" w="med" len="med"/>
+                      <a:tailEnd type="none" w="med" len="med"/>
+                    </a:lnR>
+                    <a:lnT w="6350" cap="flat" cmpd="sng" algn="ctr">
+                      <a:solidFill>
+                        <a:srgbClr val="D6D3D1"/>
+                      </a:solidFill>
+                      <a:prstDash val="solid"/>
+                      <a:round/>
+                      <a:headEnd type="none" w="med" len="med"/>
+                      <a:tailEnd type="none" w="med" len="med"/>
+                    </a:lnT>
+                    <a:lnB w="6350" cap="flat" cmpd="sng" algn="ctr">
+                      <a:solidFill>
+                        <a:srgbClr val="D6D3D1"/>
+                      </a:solidFill>
+                      <a:prstDash val="solid"/>
+                      <a:round/>
+                      <a:headEnd type="none" w="med" len="med"/>
+                      <a:tailEnd type="none" w="med" len="med"/>
+                    </a:lnB>
+                    <a:solidFill>
+                      <a:srgbClr val="FFFFFF"/>
+                    </a:solidFill>
+                  </a:tcPr>
+                </a:tc>
+                <a:tc>
+                  <a:txBody>
+                    <a:bodyPr/>
+                    <a:lstStyle/>
+                    <a:p>
+                      <a:pPr indent="0" marL="0">
+                        <a:buNone/>
+                      </a:pPr>
+                      <a:r>
+                        <a:rPr lang="en-US" sz="950" dirty="0">
+                          <a:solidFill>
+                            <a:srgbClr val="1C1917"/>
+                          </a:solidFill>
+                          <a:latin typeface="Calibri" pitchFamily="34" charset="0"/>
+                          <a:ea typeface="Calibri" pitchFamily="34" charset="-122"/>
+                          <a:cs typeface="Calibri" pitchFamily="34" charset="-120"/>
+                        </a:rPr>
+                        <a:t>n/a</a:t>
+                      </a:r>
+                      <a:endParaRPr lang="en-US" sz="950" dirty="0">
+                        <a:latin typeface="Calibri" charset="0"/>
+                        <a:ea typeface="Calibri" charset="0"/>
+                        <a:cs typeface="Calibri" charset="0"/>
+                      </a:endParaRPr>
+                    </a:p>
+                  </a:txBody>
+                  <a:tcPr marL="36576" marR="36576" marT="36576" marB="36576" anchor="ctr">
+                    <a:lnL w="6350" cap="flat" cmpd="sng" algn="ctr">
+                      <a:solidFill>
+                        <a:srgbClr val="D6D3D1"/>
+                      </a:solidFill>
+                      <a:prstDash val="solid"/>
+                      <a:round/>
+                      <a:headEnd type="none" w="med" len="med"/>
+                      <a:tailEnd type="none" w="med" len="med"/>
+                    </a:lnL>
+                    <a:lnR w="6350" cap="flat" cmpd="sng" algn="ctr">
+                      <a:solidFill>
+                        <a:srgbClr val="D6D3D1"/>
+                      </a:solidFill>
+                      <a:prstDash val="solid"/>
+                      <a:round/>
+                      <a:headEnd type="none" w="med" len="med"/>
+                      <a:tailEnd type="none" w="med" len="med"/>
+                    </a:lnR>
+                    <a:lnT w="6350" cap="flat" cmpd="sng" algn="ctr">
+                      <a:solidFill>
+                        <a:srgbClr val="D6D3D1"/>
+                      </a:solidFill>
+                      <a:prstDash val="solid"/>
+                      <a:round/>
+                      <a:headEnd type="none" w="med" len="med"/>
+                      <a:tailEnd type="none" w="med" len="med"/>
+                    </a:lnT>
+                    <a:lnB w="6350" cap="flat" cmpd="sng" algn="ctr">
+                      <a:solidFill>
+                        <a:srgbClr val="D6D3D1"/>
+                      </a:solidFill>
+                      <a:prstDash val="solid"/>
+                      <a:round/>
+                      <a:headEnd type="none" w="med" len="med"/>
+                      <a:tailEnd type="none" w="med" len="med"/>
+                    </a:lnB>
+                    <a:solidFill>
+                      <a:srgbClr val="FFFFFF"/>
+                    </a:solidFill>
+                  </a:tcPr>
+                </a:tc>
+                <a:tc>
+                  <a:txBody>
+                    <a:bodyPr/>
+                    <a:lstStyle/>
+                    <a:p>
+                      <a:pPr indent="0" marL="0">
+                        <a:buNone/>
+                      </a:pPr>
+                      <a:r>
+                        <a:rPr lang="en-US" sz="950" dirty="0">
+                          <a:solidFill>
+                            <a:srgbClr val="1C1917"/>
+                          </a:solidFill>
+                          <a:latin typeface="Calibri" pitchFamily="34" charset="0"/>
+                          <a:ea typeface="Calibri" pitchFamily="34" charset="-122"/>
+                          <a:cs typeface="Calibri" pitchFamily="34" charset="-120"/>
+                        </a:rPr>
+                        <a:t>6 of 6</a:t>
+                      </a:r>
+                      <a:endParaRPr lang="en-US" sz="950" dirty="0">
+                        <a:latin typeface="Calibri" charset="0"/>
+                        <a:ea typeface="Calibri" charset="0"/>
+                        <a:cs typeface="Calibri" charset="0"/>
+                      </a:endParaRPr>
+                    </a:p>
+                  </a:txBody>
+                  <a:tcPr marL="36576" marR="36576" marT="36576" marB="36576" anchor="ctr">
+                    <a:lnL w="6350" cap="flat" cmpd="sng" algn="ctr">
+                      <a:solidFill>
+                        <a:srgbClr val="D6D3D1"/>
+                      </a:solidFill>
+                      <a:prstDash val="solid"/>
+                      <a:round/>
+                      <a:headEnd type="none" w="med" len="med"/>
+                      <a:tailEnd type="none" w="med" len="med"/>
+                    </a:lnL>
+                    <a:lnR w="6350" cap="flat" cmpd="sng" algn="ctr">
+                      <a:solidFill>
+                        <a:srgbClr val="D6D3D1"/>
+                      </a:solidFill>
+                      <a:prstDash val="solid"/>
+                      <a:round/>
+                      <a:headEnd type="none" w="med" len="med"/>
+                      <a:tailEnd type="none" w="med" len="med"/>
+                    </a:lnR>
+                    <a:lnT w="6350" cap="flat" cmpd="sng" algn="ctr">
+                      <a:solidFill>
+                        <a:srgbClr val="D6D3D1"/>
+                      </a:solidFill>
+                      <a:prstDash val="solid"/>
+                      <a:round/>
+                      <a:headEnd type="none" w="med" len="med"/>
+                      <a:tailEnd type="none" w="med" len="med"/>
+                    </a:lnT>
+                    <a:lnB w="6350" cap="flat" cmpd="sng" algn="ctr">
+                      <a:solidFill>
+                        <a:srgbClr val="D6D3D1"/>
+                      </a:solidFill>
+                      <a:prstDash val="solid"/>
+                      <a:round/>
+                      <a:headEnd type="none" w="med" len="med"/>
+                      <a:tailEnd type="none" w="med" len="med"/>
+                    </a:lnB>
+                    <a:solidFill>
+                      <a:srgbClr val="FFFFFF"/>
+                    </a:solidFill>
+                  </a:tcPr>
+                </a:tc>
+              </a:tr>
+              <a:tr h="274320">
+                <a:tc>
+                  <a:txBody>
+                    <a:bodyPr/>
+                    <a:lstStyle/>
+                    <a:p>
+                      <a:pPr indent="0" marL="0">
+                        <a:buNone/>
+                      </a:pPr>
+                      <a:r>
+                        <a:rPr lang="en-US" sz="950" dirty="0">
+                          <a:solidFill>
+                            <a:srgbClr val="1C1917"/>
+                          </a:solidFill>
+                          <a:latin typeface="Calibri" pitchFamily="34" charset="0"/>
+                          <a:ea typeface="Calibri" pitchFamily="34" charset="-122"/>
+                          <a:cs typeface="Calibri" pitchFamily="34" charset="-120"/>
+                        </a:rPr>
+                        <a:t>Model proposals: agree with reviewer (cached)</a:t>
+                      </a:r>
+                      <a:endParaRPr lang="en-US" sz="950" dirty="0">
+                        <a:latin typeface="Calibri" charset="0"/>
+                        <a:ea typeface="Calibri" charset="0"/>
+                        <a:cs typeface="Calibri" charset="0"/>
+                      </a:endParaRPr>
+                    </a:p>
+                  </a:txBody>
+                  <a:tcPr marL="36576" marR="36576" marT="36576" marB="36576" anchor="ctr">
+                    <a:lnL w="6350" cap="flat" cmpd="sng" algn="ctr">
+                      <a:solidFill>
+                        <a:srgbClr val="D6D3D1"/>
+                      </a:solidFill>
+                      <a:prstDash val="solid"/>
+                      <a:round/>
+                      <a:headEnd type="none" w="med" len="med"/>
+                      <a:tailEnd type="none" w="med" len="med"/>
+                    </a:lnL>
+                    <a:lnR w="6350" cap="flat" cmpd="sng" algn="ctr">
+                      <a:solidFill>
+                        <a:srgbClr val="D6D3D1"/>
+                      </a:solidFill>
+                      <a:prstDash val="solid"/>
+                      <a:round/>
+                      <a:headEnd type="none" w="med" len="med"/>
+                      <a:tailEnd type="none" w="med" len="med"/>
+                    </a:lnR>
+                    <a:lnT w="6350" cap="flat" cmpd="sng" algn="ctr">
+                      <a:solidFill>
+                        <a:srgbClr val="D6D3D1"/>
+                      </a:solidFill>
+                      <a:prstDash val="solid"/>
+                      <a:round/>
+                      <a:headEnd type="none" w="med" len="med"/>
+                      <a:tailEnd type="none" w="med" len="med"/>
+                    </a:lnT>
+                    <a:lnB w="6350" cap="flat" cmpd="sng" algn="ctr">
+                      <a:solidFill>
+                        <a:srgbClr val="D6D3D1"/>
+                      </a:solidFill>
+                      <a:prstDash val="solid"/>
+                      <a:round/>
+                      <a:headEnd type="none" w="med" len="med"/>
+                      <a:tailEnd type="none" w="med" len="med"/>
+                    </a:lnB>
+                    <a:solidFill>
+                      <a:srgbClr val="FFFFFF"/>
+                    </a:solidFill>
+                  </a:tcPr>
+                </a:tc>
+                <a:tc>
+                  <a:txBody>
+                    <a:bodyPr/>
+                    <a:lstStyle/>
+                    <a:p>
+                      <a:pPr indent="0" marL="0">
+                        <a:buNone/>
+                      </a:pPr>
+                      <a:r>
+                        <a:rPr lang="en-US" sz="950" dirty="0">
+                          <a:solidFill>
+                            <a:srgbClr val="1C1917"/>
+                          </a:solidFill>
+                          <a:latin typeface="Calibri" pitchFamily="34" charset="0"/>
+                          <a:ea typeface="Calibri" pitchFamily="34" charset="-122"/>
+                          <a:cs typeface="Calibri" pitchFamily="34" charset="-120"/>
+                        </a:rPr>
+                        <a:t>n/a</a:t>
+                      </a:r>
+                      <a:endParaRPr lang="en-US" sz="950" dirty="0">
+                        <a:latin typeface="Calibri" charset="0"/>
+                        <a:ea typeface="Calibri" charset="0"/>
+                        <a:cs typeface="Calibri" charset="0"/>
+                      </a:endParaRPr>
+                    </a:p>
+                  </a:txBody>
+                  <a:tcPr marL="36576" marR="36576" marT="36576" marB="36576" anchor="ctr">
+                    <a:lnL w="6350" cap="flat" cmpd="sng" algn="ctr">
+                      <a:solidFill>
+                        <a:srgbClr val="D6D3D1"/>
+                      </a:solidFill>
+                      <a:prstDash val="solid"/>
+                      <a:round/>
+                      <a:headEnd type="none" w="med" len="med"/>
+                      <a:tailEnd type="none" w="med" len="med"/>
+                    </a:lnL>
+                    <a:lnR w="6350" cap="flat" cmpd="sng" algn="ctr">
+                      <a:solidFill>
+                        <a:srgbClr val="D6D3D1"/>
+                      </a:solidFill>
+                      <a:prstDash val="solid"/>
+                      <a:round/>
+                      <a:headEnd type="none" w="med" len="med"/>
+                      <a:tailEnd type="none" w="med" len="med"/>
+                    </a:lnR>
+                    <a:lnT w="6350" cap="flat" cmpd="sng" algn="ctr">
+                      <a:solidFill>
+                        <a:srgbClr val="D6D3D1"/>
+                      </a:solidFill>
+                      <a:prstDash val="solid"/>
+                      <a:round/>
+                      <a:headEnd type="none" w="med" len="med"/>
+                      <a:tailEnd type="none" w="med" len="med"/>
+                    </a:lnT>
+                    <a:lnB w="6350" cap="flat" cmpd="sng" algn="ctr">
+                      <a:solidFill>
+                        <a:srgbClr val="D6D3D1"/>
+                      </a:solidFill>
+                      <a:prstDash val="solid"/>
+                      <a:round/>
+                      <a:headEnd type="none" w="med" len="med"/>
+                      <a:tailEnd type="none" w="med" len="med"/>
+                    </a:lnB>
+                    <a:solidFill>
+                      <a:srgbClr val="FFFFFF"/>
+                    </a:solidFill>
+                  </a:tcPr>
+                </a:tc>
+                <a:tc>
+                  <a:txBody>
+                    <a:bodyPr/>
+                    <a:lstStyle/>
+                    <a:p>
+                      <a:pPr indent="0" marL="0">
+                        <a:buNone/>
+                      </a:pPr>
+                      <a:r>
+                        <a:rPr lang="en-US" sz="950" dirty="0">
+                          <a:solidFill>
+                            <a:srgbClr val="1C1917"/>
+                          </a:solidFill>
+                          <a:latin typeface="Calibri" pitchFamily="34" charset="0"/>
+                          <a:ea typeface="Calibri" pitchFamily="34" charset="-122"/>
+                          <a:cs typeface="Calibri" pitchFamily="34" charset="-120"/>
+                        </a:rPr>
+                        <a:t>11 of 13</a:t>
+                      </a:r>
+                      <a:endParaRPr lang="en-US" sz="950" dirty="0">
+                        <a:latin typeface="Calibri" charset="0"/>
+                        <a:ea typeface="Calibri" charset="0"/>
+                        <a:cs typeface="Calibri" charset="0"/>
+                      </a:endParaRPr>
+                    </a:p>
+                  </a:txBody>
+                  <a:tcPr marL="36576" marR="36576" marT="36576" marB="36576" anchor="ctr">
                     <a:lnL w="6350" cap="flat" cmpd="sng" algn="ctr">
                       <a:solidFill>
                         <a:srgbClr val="D6D3D1"/>
@@ -6171,8 +6631,8 @@
         </p:nvSpPr>
         <p:spPr>
           <a:xfrm>
-            <a:off x="4572000" y="3429000"/>
-            <a:ext cx="4114800" cy="1097280"/>
+            <a:off x="4572000" y="3794760"/>
+            <a:ext cx="4114800" cy="822960"/>
           </a:xfrm>
           <a:prstGeom prst="rect">
             <a:avLst/>
@@ -6188,14 +6648,14 @@
               <a:buNone/>
             </a:pPr>
             <a:r>
-              <a:rPr lang="en-US" sz="1050" dirty="0">
+              <a:rPr lang="en-US" sz="950" dirty="0">
                 <a:solidFill>
                   <a:schemeClr val="tx2"/>
                 </a:solidFill>
               </a:rPr>
-              <a:t>All four measures run on the synthetic demo wording only and say nothing about real policies. The product shows no accuracy figure anywhere. Figures on this slide are potential deductions covered by the simulation, never total out-of-pocket cost.</a:t>
-            </a:r>
-            <a:endParaRPr lang="en-US" sz="1050" dirty="0"/>
+              <a:t>Measured on the synthetic wording and on ten encoded clauses of one real wording; the model proposals are cached, not a live run. The product shows no accuracy figure anywhere. Figures on this slide are potential deductions covered by the simulation, never total out-of-pocket cost.</a:t>
+            </a:r>
+            <a:endParaRPr lang="en-US" sz="950" dirty="0"/>
           </a:p>
         </p:txBody>
       </p:sp>
@@ -6478,7 +6938,7 @@
                   <a:schemeClr val="tx1"/>
                 </a:solidFill>
               </a:rPr>
-              <a:t>It already offers claim assistance by phone.</a:t>
+              <a:t>It already offers claim assistance by phone. Arogya Sanjeevani is IRDAI's standard product on one wording; one verified encoding serves every insurer that sells it.</a:t>
             </a:r>
             <a:endParaRPr lang="en-US" sz="1150" dirty="0"/>
           </a:p>
@@ -7499,7 +7959,7 @@
                   <a:schemeClr val="accent6"/>
                 </a:solidFill>
               </a:rPr>
-              <a:t>124 unit tests · 13 acceptance cases · 4 evaluation measures · a trace on every number · synthetic policy, labelled everywhere</a:t>
+              <a:t>180 unit tests · two wordings, one of them real · six evaluation measures · a ruleset builder where a model proposes and a person confirms · a trace on every number</a:t>
             </a:r>
             <a:endParaRPr lang="en-US" sz="1400" dirty="0"/>
           </a:p>
@@ -7513,7 +7973,7 @@
                   <a:schemeClr val="accent6"/>
                 </a:solidFill>
               </a:rPr>
-              <a:t>Next: encode one verified real wording through the same adapter; independent review of the evaluation fixtures; a pilot at a broker's claim-assistance desk.</a:t>
+              <a:t>Next: a second real wording through the builder with the live adapter on; independent review of the evaluation fixtures; a four-week pilot at a broker's claim-assistance desk.</a:t>
             </a:r>
             <a:endParaRPr lang="en-US" sz="1400" dirty="0"/>
           </a:p>

</xml_diff>